<commit_message>
Rewrite slide 5 bet-comparison rows in plain language
Renamed the four row labels to Value, Key Metric Improved, Choose if,
and Risk. Rewrote every cell as a complete sentence a reader parses on
first pass.

The "Choose if" row drove the change. "Exits cluster early and themes
read confusion and isolation, not wage" compressed a conditional into
noun stacks and stopped meaning anything. It now reads "New hires quit
early, and exit interviews blame confusion and isolation, not pay."

Slide 5 re-rendered and inspected: no overflow, no cell collisions,
table clears the do-nothing band. Outline wireframe updated to match.

Co-Authored-By: Claude Opus 5 <noreply@anthropic.com>
Claude-Session: https://claude.ai/code/session_01XDKkRhz8qUyB8z7TiT732w
</commit_message>
<xml_diff>
--- a/docs/sidekick-90-day-decision-deck.pptx
+++ b/docs/sidekick-90-day-decision-deck.pptx
@@ -27156,7 +27156,7 @@
                           <a:ea typeface="Calibri" pitchFamily="34" charset="-122"/>
                           <a:cs typeface="Calibri" pitchFamily="34" charset="-120"/>
                         </a:rPr>
-                        <a:t>Worth</a:t>
+                        <a:t>Value</a:t>
                       </a:r>
                       <a:endParaRPr lang="en-US" sz="1100" dirty="0">
                         <a:latin typeface="Calibri" charset="0"/>
@@ -27224,7 +27224,7 @@
                           <a:ea typeface="Calibri" pitchFamily="34" charset="-122"/>
                           <a:cs typeface="Calibri" pitchFamily="34" charset="-120"/>
                         </a:rPr>
-                        <a:t>~$15M a year per point of 90-day retention</a:t>
+                        <a:t>$15M a year for every 1 point gained in 90-day retention</a:t>
                       </a:r>
                       <a:endParaRPr lang="en-US" sz="1100" dirty="0">
                         <a:latin typeface="Calibri" charset="0"/>
@@ -27289,7 +27289,7 @@
                           <a:ea typeface="Calibri" pitchFamily="34" charset="-122"/>
                           <a:cs typeface="Calibri" pitchFamily="34" charset="-120"/>
                         </a:rPr>
-                        <a:t>~$100M a year per minute returned per shift</a:t>
+                        <a:t>$100M a year for every 1 minute given back per shift</a:t>
                       </a:r>
                       <a:endParaRPr lang="en-US" sz="1100" dirty="0">
                         <a:latin typeface="Calibri" charset="0"/>
@@ -27354,7 +27354,7 @@
                           <a:ea typeface="Calibri" pitchFamily="34" charset="-122"/>
                           <a:cs typeface="Calibri" pitchFamily="34" charset="-120"/>
                         </a:rPr>
-                        <a:t>~2x retention yield on the same incentive dollar</a:t>
+                        <a:t>About 2x the retention gain from the same incentive budget</a:t>
                       </a:r>
                       <a:endParaRPr lang="en-US" sz="1100" dirty="0">
                         <a:latin typeface="Calibri" charset="0"/>
@@ -27421,7 +27421,7 @@
                           <a:ea typeface="Calibri" pitchFamily="34" charset="-122"/>
                           <a:cs typeface="Calibri" pitchFamily="34" charset="-120"/>
                         </a:rPr>
-                        <a:t>North star</a:t>
+                        <a:t>Key Metric Improved</a:t>
                       </a:r>
                       <a:endParaRPr lang="en-US" sz="1100" dirty="0">
                         <a:latin typeface="Calibri" charset="0"/>
@@ -27489,7 +27489,7 @@
                           <a:ea typeface="Calibri" pitchFamily="34" charset="-122"/>
                           <a:cs typeface="Calibri" pitchFamily="34" charset="-120"/>
                         </a:rPr>
-                        <a:t>90-day new-hire retention, pilot vs control stores</a:t>
+                        <a:t>90-day new-hire retention, pilot stores vs control stores</a:t>
                       </a:r>
                       <a:endParaRPr lang="en-US" sz="1100" dirty="0">
                         <a:latin typeface="Calibri" charset="0"/>
@@ -27554,7 +27554,7 @@
                           <a:ea typeface="Calibri" pitchFamily="34" charset="-122"/>
                           <a:cs typeface="Calibri" pitchFamily="34" charset="-120"/>
                         </a:rPr>
-                        <a:t>Minutes of associate time returned per week</a:t>
+                        <a:t>Minutes of work time returned per associate per week</a:t>
                       </a:r>
                       <a:endParaRPr lang="en-US" sz="1100" dirty="0">
                         <a:latin typeface="Calibri" charset="0"/>
@@ -27619,7 +27619,7 @@
                           <a:ea typeface="Calibri" pitchFamily="34" charset="-122"/>
                           <a:cs typeface="Calibri" pitchFamily="34" charset="-120"/>
                         </a:rPr>
-                        <a:t>Predicted vs actual lift in bandit cohorts, with holdouts</a:t>
+                        <a:t>Predicted vs actual retention lift, measured against holdouts</a:t>
                       </a:r>
                       <a:endParaRPr lang="en-US" sz="1100" dirty="0">
                         <a:latin typeface="Calibri" charset="0"/>
@@ -27754,7 +27754,7 @@
                           <a:ea typeface="Calibri" pitchFamily="34" charset="-122"/>
                           <a:cs typeface="Calibri" pitchFamily="34" charset="-120"/>
                         </a:rPr>
-                        <a:t>Exits cluster early and themes read confusion and isolation, not wage</a:t>
+                        <a:t>New hires quit early, and exit interviews blame confusion and isolation, not pay</a:t>
                       </a:r>
                       <a:endParaRPr lang="en-US" sz="1100" dirty="0">
                         <a:latin typeface="Calibri" charset="0"/>
@@ -27819,7 +27819,7 @@
                           <a:ea typeface="Calibri" pitchFamily="34" charset="-122"/>
                           <a:cs typeface="Calibri" pitchFamily="34" charset="-120"/>
                         </a:rPr>
-                        <a:t>High question volume dead-ends into manual handoffs</a:t>
+                        <a:t>Associates ask the same questions constantly, and answers dead-end in a manual handoff</a:t>
                       </a:r>
                       <a:endParaRPr lang="en-US" sz="1100" dirty="0">
                         <a:latin typeface="Calibri" charset="0"/>
@@ -27884,7 +27884,7 @@
                           <a:ea typeface="Calibri" pitchFamily="34" charset="-122"/>
                           <a:cs typeface="Calibri" pitchFamily="34" charset="-120"/>
                         </a:rPr>
-                        <a:t>Attrition drivers vary sharply by cohort and there is appetite for platform spend</a:t>
+                        <a:t>Different groups quit for different reasons, and there is budget for a platform</a:t>
                       </a:r>
                       <a:endParaRPr lang="en-US" sz="1100" dirty="0">
                         <a:latin typeface="Calibri" charset="0"/>
@@ -27951,7 +27951,7 @@
                           <a:ea typeface="Calibri" pitchFamily="34" charset="-122"/>
                           <a:cs typeface="Calibri" pitchFamily="34" charset="-120"/>
                         </a:rPr>
-                        <a:t>Main risk</a:t>
+                        <a:t>Risk</a:t>
                       </a:r>
                       <a:endParaRPr lang="en-US" sz="1100" dirty="0">
                         <a:latin typeface="Calibri" charset="0"/>
@@ -28019,7 +28019,7 @@
                           <a:ea typeface="Calibri" pitchFamily="34" charset="-122"/>
                           <a:cs typeface="Calibri" pitchFamily="34" charset="-120"/>
                         </a:rPr>
-                        <a:t>Retention is multi-causal. The app moves only its share</a:t>
+                        <a:t>People quit for many reasons. An app only moves the ones it touches</a:t>
                       </a:r>
                       <a:endParaRPr lang="en-US" sz="1100" dirty="0">
                         <a:latin typeface="Calibri" charset="0"/>
@@ -28084,7 +28084,7 @@
                           <a:ea typeface="Calibri" pitchFamily="34" charset="-122"/>
                           <a:cs typeface="Calibri" pitchFamily="34" charset="-120"/>
                         </a:rPr>
-                        <a:t>Actions touch systems of record. One wrong write costs more trust than 100 right answers earn</a:t>
+                        <a:t>Agents write into scheduling and HR systems. One bad write undoes 100 right answers</a:t>
                       </a:r>
                       <a:endParaRPr lang="en-US" sz="1100" dirty="0">
                         <a:latin typeface="Calibri" charset="0"/>
@@ -28149,7 +28149,7 @@
                           <a:ea typeface="Calibri" pitchFamily="34" charset="-122"/>
                           <a:cs typeface="Calibri" pitchFamily="34" charset="-120"/>
                         </a:rPr>
-                        <a:t>Scoring can read as surveillance. Slowest path to a visible win</a:t>
+                        <a:t>Scoring associates can feel like surveillance. Slowest bet to show a visible win</a:t>
                       </a:r>
                       <a:endParaRPr lang="en-US" sz="1100" dirty="0">
                         <a:latin typeface="Calibri" charset="0"/>

</xml_diff>